<commit_message>
Enforce reconstruction fidelity contracts
</commit_message>
<xml_diff>
--- a/examples/consulting-ai-transformation/deliverables/presentation.pptx
+++ b/examples/consulting-ai-transformation/deliverables/presentation.pptx
@@ -120,7 +120,7 @@
     <c:plotArea>
       <c:layout/>
       <c:barChart>
-        <c:barDir val="bar"/>
+        <c:barDir val="col"/>
         <c:grouping val="clustered"/>
         <c:varyColors val="0"/>
         <c:ser>
@@ -280,11 +280,11 @@
           <c:orientation val="minMax"/>
         </c:scaling>
         <c:delete val="0"/>
-        <c:axPos val="l"/>
+        <c:axPos val="b"/>
         <c:numFmt formatCode="General" sourceLinked="1"/>
         <c:majorTickMark val="out"/>
         <c:minorTickMark val="none"/>
-        <c:tickLblPos val="nextTo"/>
+        <c:tickLblPos val="low"/>
         <c:spPr>
           <a:ln w="12700" cap="flat">
             <a:solidFill>
@@ -323,7 +323,7 @@
           <c:min val="0"/>
         </c:scaling>
         <c:delete val="0"/>
-        <c:axPos val="b"/>
+        <c:axPos val="l"/>
         <c:majorGridlines>
           <c:spPr>
             <a:ln w="12700" cap="flat">
@@ -338,7 +338,7 @@
         <c:numFmt formatCode="General" sourceLinked="0"/>
         <c:majorTickMark val="out"/>
         <c:minorTickMark val="none"/>
-        <c:tickLblPos val="low"/>
+        <c:tickLblPos val="nextTo"/>
         <c:spPr>
           <a:ln w="12700" cap="flat">
             <a:solidFill>
@@ -792,7 +792,7 @@
 The 95% gate applies to a sampled test set. Each client release separately requires expert verification and engagement-lead approval.
 At least 11 of 15 pilot users must be weekly active. One comparable research task is measured per pilot engagement.
 [SlidePoise sources]
-Generated target visual: /private/tmp/.slidepoise-rebuild-jkaybi9w/slides/s01-recommendation/work/accepted-slide.png
+Generated target visual: /private/tmp/.slidepoise-rebuild-h51errnw/slides/s01-recommendation/work/accepted-slide.png
 Canonical asset remix-focus-2-line: /Users/henry/Codes/AI_slide_drafting/examples/consulting-ai-transformation/run/work/icon-cache/focus-2/remix-focus-2-line.svg
 Canonical asset remix-team-line: /Users/henry/Codes/AI_slide_drafting/examples/consulting-ai-transformation/run/work/icon-cache/team/remix-team-line.svg
 Canonical asset remix-shield-check-line: /Users/henry/Codes/AI_slide_drafting/examples/consulting-ai-transformation/run/work/icon-cache/shield-check/remix-shield-check-line.svg</a:t>
@@ -886,7 +886,7 @@
               <a:t>This is an illustrative planning model for fictional Northstar Advisory. Annual capacity assumes 900 engagements. Research uses 900 x 12 baseline hours x 60% adoption x 30% time saved = 1,944 hours. The same formula produces 1,440 proposal hours and 1,080 retrieval hours from the displayed assumptions.
 The three workflow estimates may overlap and cannot be added without checking task boundaries. Capacity released is not a cash saving. Control readiness determines the proposed sequence, and expert review remains required before any client release.
 [SlidePoise sources]
-Generated target visual: /private/tmp/.slidepoise-rebuild-jkaybi9w/slides/s02-opportunities/work/accepted-slide.png
+Generated target visual: /private/tmp/.slidepoise-rebuild-h51errnw/slides/s02-opportunities/work/accepted-slide.png
 Canonical asset remix-file-search-line: /Users/henry/Codes/AI_slide_drafting/examples/consulting-ai-transformation/run/work/icon-cache/file-search/remix-file-search-line.svg
 Canonical asset remix-database-2-line: /Users/henry/Codes/AI_slide_drafting/examples/consulting-ai-transformation/run/work/icon-cache/database-2/remix-database-2-line.svg
 Canonical asset remix-user-star-line: /Users/henry/Codes/AI_slide_drafting/examples/consulting-ai-transformation/run/work/icon-cache/user-star/remix-user-star-line.svg</a:t>
@@ -980,7 +980,7 @@
               <a:t>This is an illustrative planning scenario. Twenty paired tasks represent one research task from each of twenty pilot engagements, with ten tasks at the week-eight interim review. The sampled 95% claim-verification gate measures pilot quality. Every client claim still requires expert sign-off and every client release requires engagement-lead approval.
 The two curved feedback paths are editable native freeforms. They preserve the observed direction and curve geometry, but moving the table or its columns in Office does not automatically reattach these paths.
 [SlidePoise sources]
-Generated target visual: /private/tmp/.slidepoise-rebuild-jkaybi9w/slides/s03-operating-model/work/accepted-slide.png
+Generated target visual: /private/tmp/.slidepoise-rebuild-h51errnw/slides/s03-operating-model/work/accepted-slide.png
 Canonical asset remix-file-search-line: /Users/henry/Codes/AI_slide_drafting/examples/consulting-ai-transformation/run/work/icon-cache/file-search/remix-file-search-line.svg
 Canonical asset remix-draft-line: /Users/henry/Codes/AI_slide_drafting/examples/consulting-ai-transformation/run/work/icon-cache/draft/remix-draft-line.svg
 Canonical asset remix-shield-check-line: /Users/henry/Codes/AI_slide_drafting/examples/consulting-ai-transformation/run/work/icon-cache/shield-check/remix-shield-check-line.svg
@@ -1075,7 +1075,7 @@
               <a:t>Each pilot engagement supplies one research task. Twenty paired tasks correspond to twenty engagements.
 The practice lead and CFO release scale funding only after the evidence gates are reviewed. Critical data exceptions stop expansion.
 [SlidePoise sources]
-Generated target visual: /private/tmp/.slidepoise-rebuild-jkaybi9w/slides/s04-delivery-roadmap/work/accepted-slide.png
+Generated target visual: /private/tmp/.slidepoise-rebuild-h51errnw/slides/s04-delivery-roadmap/work/accepted-slide.png
 Canonical asset remix-flag-line: /Users/henry/Codes/AI_slide_drafting/examples/consulting-ai-transformation/run/work/icon-cache/flag/remix-flag-line.svg</a:t>
             </a:r>
             <a:endParaRPr lang="en-US" dirty="0"/>
@@ -1165,7 +1165,7 @@
             <a:r>
               <a:rPr lang="en-US" dirty="0"/>
               <a:t>[SlidePoise sources]
-Generated target visual: /private/tmp/.slidepoise-rebuild-jkaybi9w/slides/s05-investment-decision/work/accepted-slide.png
+Generated target visual: /private/tmp/.slidepoise-rebuild-h51errnw/slides/s05-investment-decision/work/accepted-slide.png
 Canonical asset remix-play-circle-line: /Users/henry/Codes/AI_slide_drafting/examples/consulting-ai-transformation/run/work/icon-cache/play-circle/remix-play-circle-line.svg
 Canonical asset remix-pause-circle-line: /Users/henry/Codes/AI_slide_drafting/examples/consulting-ai-transformation/run/work/icon-cache/pause-circle/remix-pause-circle-line.svg
 Canonical asset remix-stop-circle-line: /Users/henry/Codes/AI_slide_drafting/examples/consulting-ai-transformation/run/work/icon-cache/stop-circle/remix-stop-circle-line.svg</a:t>
@@ -12655,8 +12655,8 @@
         </p:nvCxnSpPr>
         <p:spPr>
           <a:xfrm>
-            <a:off x="1739900" y="4800600"/>
-            <a:ext cx="1758950" cy="0"/>
+            <a:off x="1549400" y="4800600"/>
+            <a:ext cx="1663700" cy="0"/>
           </a:xfrm>
           <a:prstGeom prst="line">
             <a:avLst/>
@@ -12681,8 +12681,8 @@
         </p:nvCxnSpPr>
         <p:spPr>
           <a:xfrm>
-            <a:off x="3803650" y="4800600"/>
-            <a:ext cx="1758950" cy="0"/>
+            <a:off x="3517900" y="4800600"/>
+            <a:ext cx="1663700" cy="0"/>
           </a:xfrm>
           <a:prstGeom prst="line">
             <a:avLst/>
@@ -12707,8 +12707,8 @@
         </p:nvCxnSpPr>
         <p:spPr>
           <a:xfrm>
-            <a:off x="5867400" y="4800600"/>
-            <a:ext cx="1758950" cy="0"/>
+            <a:off x="5486400" y="4800600"/>
+            <a:ext cx="1663700" cy="0"/>
           </a:xfrm>
           <a:prstGeom prst="line">
             <a:avLst/>
@@ -12868,7 +12868,7 @@
         </p:nvSpPr>
         <p:spPr>
           <a:xfrm>
-            <a:off x="762000" y="5035550"/>
+            <a:off x="571500" y="5035550"/>
             <a:ext cx="1651000" cy="203200"/>
           </a:xfrm>
           <a:prstGeom prst="rect">
@@ -12913,7 +12913,7 @@
         </p:nvSpPr>
         <p:spPr>
           <a:xfrm>
-            <a:off x="635000" y="5251450"/>
+            <a:off x="444500" y="5251450"/>
             <a:ext cx="1905000" cy="222250"/>
           </a:xfrm>
           <a:prstGeom prst="rect">
@@ -12958,7 +12958,7 @@
         </p:nvSpPr>
         <p:spPr>
           <a:xfrm>
-            <a:off x="2825750" y="5035550"/>
+            <a:off x="2540000" y="5035550"/>
             <a:ext cx="1651000" cy="203200"/>
           </a:xfrm>
           <a:prstGeom prst="rect">
@@ -13003,7 +13003,7 @@
         </p:nvSpPr>
         <p:spPr>
           <a:xfrm>
-            <a:off x="2698750" y="5251450"/>
+            <a:off x="2413000" y="5251450"/>
             <a:ext cx="1905000" cy="222250"/>
           </a:xfrm>
           <a:prstGeom prst="rect">
@@ -13048,7 +13048,7 @@
         </p:nvSpPr>
         <p:spPr>
           <a:xfrm>
-            <a:off x="4889500" y="5035550"/>
+            <a:off x="4508500" y="5035550"/>
             <a:ext cx="1651000" cy="203200"/>
           </a:xfrm>
           <a:prstGeom prst="rect">
@@ -13093,7 +13093,7 @@
         </p:nvSpPr>
         <p:spPr>
           <a:xfrm>
-            <a:off x="4762500" y="5251450"/>
+            <a:off x="4381500" y="5251450"/>
             <a:ext cx="1905000" cy="222250"/>
           </a:xfrm>
           <a:prstGeom prst="rect">
@@ -13138,7 +13138,7 @@
         </p:nvSpPr>
         <p:spPr>
           <a:xfrm>
-            <a:off x="6953250" y="5035550"/>
+            <a:off x="6477000" y="5035550"/>
             <a:ext cx="1651000" cy="203200"/>
           </a:xfrm>
           <a:prstGeom prst="rect">
@@ -13183,7 +13183,7 @@
         </p:nvSpPr>
         <p:spPr>
           <a:xfrm>
-            <a:off x="6826250" y="5251450"/>
+            <a:off x="6350000" y="5251450"/>
             <a:ext cx="1905000" cy="222250"/>
           </a:xfrm>
           <a:prstGeom prst="rect">
@@ -13512,7 +13512,7 @@
         </p:blipFill>
         <p:spPr>
           <a:xfrm>
-            <a:off x="1447800" y="4660900"/>
+            <a:off x="1257300" y="4660900"/>
             <a:ext cx="279400" cy="279400"/>
           </a:xfrm>
           <a:prstGeom prst="rect">
@@ -13542,7 +13542,7 @@
         </p:blipFill>
         <p:spPr>
           <a:xfrm>
-            <a:off x="3511550" y="4660900"/>
+            <a:off x="3225800" y="4660900"/>
             <a:ext cx="279400" cy="279400"/>
           </a:xfrm>
           <a:prstGeom prst="rect">
@@ -13572,7 +13572,7 @@
         </p:blipFill>
         <p:spPr>
           <a:xfrm>
-            <a:off x="5575300" y="4660900"/>
+            <a:off x="5194300" y="4660900"/>
             <a:ext cx="279400" cy="279400"/>
           </a:xfrm>
           <a:prstGeom prst="rect">
@@ -13602,7 +13602,7 @@
         </p:blipFill>
         <p:spPr>
           <a:xfrm>
-            <a:off x="7639050" y="4660900"/>
+            <a:off x="7162800" y="4660900"/>
             <a:ext cx="279400" cy="279400"/>
           </a:xfrm>
           <a:prstGeom prst="rect">

</xml_diff>